<commit_message>
Initial commit: add project files
</commit_message>
<xml_diff>
--- a/ppt_pics1_deck.pptx
+++ b/ppt_pics1_deck.pptx
@@ -5,43 +5,44 @@
     <p:sldMasterId id="2147483648" r:id="rId1"/>
   </p:sldMasterIdLst>
   <p:sldIdLst>
-    <p:sldId id="256" r:id="rId8"/>
-    <p:sldId id="257" r:id="rId9"/>
-    <p:sldId id="258" r:id="rId10"/>
-    <p:sldId id="259" r:id="rId11"/>
-    <p:sldId id="260" r:id="rId12"/>
-    <p:sldId id="261" r:id="rId13"/>
-    <p:sldId id="262" r:id="rId14"/>
-    <p:sldId id="263" r:id="rId15"/>
-    <p:sldId id="264" r:id="rId16"/>
-    <p:sldId id="265" r:id="rId17"/>
-    <p:sldId id="266" r:id="rId18"/>
-    <p:sldId id="267" r:id="rId19"/>
-    <p:sldId id="268" r:id="rId20"/>
-    <p:sldId id="269" r:id="rId21"/>
-    <p:sldId id="270" r:id="rId22"/>
-    <p:sldId id="271" r:id="rId23"/>
-    <p:sldId id="272" r:id="rId24"/>
-    <p:sldId id="273" r:id="rId25"/>
-    <p:sldId id="274" r:id="rId26"/>
-    <p:sldId id="275" r:id="rId27"/>
-    <p:sldId id="276" r:id="rId28"/>
-    <p:sldId id="277" r:id="rId29"/>
-    <p:sldId id="278" r:id="rId30"/>
-    <p:sldId id="279" r:id="rId31"/>
-    <p:sldId id="280" r:id="rId32"/>
-    <p:sldId id="281" r:id="rId33"/>
-    <p:sldId id="282" r:id="rId34"/>
-    <p:sldId id="283" r:id="rId35"/>
-    <p:sldId id="284" r:id="rId36"/>
-    <p:sldId id="285" r:id="rId37"/>
-    <p:sldId id="286" r:id="rId38"/>
-    <p:sldId id="287" r:id="rId39"/>
+    <p:sldId id="256" r:id="rId2"/>
+    <p:sldId id="257" r:id="rId3"/>
+    <p:sldId id="258" r:id="rId4"/>
+    <p:sldId id="259" r:id="rId5"/>
+    <p:sldId id="260" r:id="rId6"/>
+    <p:sldId id="261" r:id="rId7"/>
+    <p:sldId id="262" r:id="rId8"/>
+    <p:sldId id="263" r:id="rId9"/>
+    <p:sldId id="264" r:id="rId10"/>
+    <p:sldId id="265" r:id="rId11"/>
+    <p:sldId id="266" r:id="rId12"/>
+    <p:sldId id="267" r:id="rId13"/>
+    <p:sldId id="268" r:id="rId14"/>
+    <p:sldId id="269" r:id="rId15"/>
+    <p:sldId id="270" r:id="rId16"/>
+    <p:sldId id="271" r:id="rId17"/>
+    <p:sldId id="272" r:id="rId18"/>
+    <p:sldId id="273" r:id="rId19"/>
+    <p:sldId id="274" r:id="rId20"/>
+    <p:sldId id="275" r:id="rId21"/>
+    <p:sldId id="276" r:id="rId22"/>
+    <p:sldId id="277" r:id="rId23"/>
+    <p:sldId id="278" r:id="rId24"/>
+    <p:sldId id="279" r:id="rId25"/>
+    <p:sldId id="280" r:id="rId26"/>
+    <p:sldId id="281" r:id="rId27"/>
+    <p:sldId id="282" r:id="rId28"/>
+    <p:sldId id="283" r:id="rId29"/>
+    <p:sldId id="284" r:id="rId30"/>
+    <p:sldId id="285" r:id="rId31"/>
+    <p:sldId id="286" r:id="rId32"/>
+    <p:sldId id="287" r:id="rId33"/>
+    <p:sldId id="288" r:id="rId34"/>
   </p:sldIdLst>
   <p:sldSz cx="9144000" cy="6858000" type="screen4x3"/>
   <p:notesSz cx="6858000" cy="9144000"/>
   <p:custDataLst>
-    <p:tags r:id="rId3"/>
+    <p:tags r:id="rId35"/>
   </p:custDataLst>
   <p:defaultTextStyle>
     <a:defPPr>
@@ -138,7 +139,52 @@
       </a:defRPr>
     </a:lvl9pPr>
   </p:defaultTextStyle>
+  <p:extLst>
+    <p:ext uri="{EFAFB233-063F-42B5-8137-9DF3F51BA10A}">
+      <p15:sldGuideLst xmlns:p15="http://schemas.microsoft.com/office/powerpoint/2012/main">
+        <p15:guide id="1" orient="horz" pos="2160">
+          <p15:clr>
+            <a:srgbClr val="A4A3A4"/>
+          </p15:clr>
+        </p15:guide>
+        <p15:guide id="2" pos="2880">
+          <p15:clr>
+            <a:srgbClr val="A4A3A4"/>
+          </p15:clr>
+        </p15:guide>
+      </p15:sldGuideLst>
+    </p:ext>
+  </p:extLst>
 </p:presentation>
+</file>
+
+<file path=ppt/changesInfos/changesInfo1.xml><?xml version="1.0" encoding="utf-8"?>
+<pc:chgInfo xmlns:a="http://schemas.openxmlformats.org/drawingml/2006/main" xmlns:r="http://schemas.openxmlformats.org/officeDocument/2006/relationships" xmlns:ac="http://schemas.microsoft.com/office/drawing/2013/main/command" xmlns:pc="http://schemas.microsoft.com/office/powerpoint/2013/main/command">
+  <pc:docChgLst>
+    <pc:chgData name="Rahul Narnindi" userId="f3058f02-7ce8-4b12-b78c-a6a889518139" providerId="ADAL" clId="{584583A4-7F0B-494E-B8E0-BC76AF6A536D}"/>
+    <pc:docChg chg="addSld modSld">
+      <pc:chgData name="Rahul Narnindi" userId="f3058f02-7ce8-4b12-b78c-a6a889518139" providerId="ADAL" clId="{584583A4-7F0B-494E-B8E0-BC76AF6A536D}" dt="2026-03-04T09:35:48.426" v="4" actId="20577"/>
+      <pc:docMkLst>
+        <pc:docMk/>
+      </pc:docMkLst>
+      <pc:sldChg chg="modSp new mod">
+        <pc:chgData name="Rahul Narnindi" userId="f3058f02-7ce8-4b12-b78c-a6a889518139" providerId="ADAL" clId="{584583A4-7F0B-494E-B8E0-BC76AF6A536D}" dt="2026-03-04T09:35:48.426" v="4" actId="20577"/>
+        <pc:sldMkLst>
+          <pc:docMk/>
+          <pc:sldMk cId="1463186371" sldId="288"/>
+        </pc:sldMkLst>
+        <pc:spChg chg="mod">
+          <ac:chgData name="Rahul Narnindi" userId="f3058f02-7ce8-4b12-b78c-a6a889518139" providerId="ADAL" clId="{584583A4-7F0B-494E-B8E0-BC76AF6A536D}" dt="2026-03-04T09:35:48.426" v="4" actId="20577"/>
+          <ac:spMkLst>
+            <pc:docMk/>
+            <pc:sldMk cId="1463186371" sldId="288"/>
+            <ac:spMk id="2" creationId="{6B9C9EBF-4F03-7DA7-E505-32DE54D0DBBA}"/>
+          </ac:spMkLst>
+        </pc:spChg>
+      </pc:sldChg>
+    </pc:docChg>
+  </pc:docChgLst>
+</pc:chgInfo>
 </file>
 
 <file path=ppt/slideLayouts/slideLayout1.xml><?xml version="1.0" encoding="utf-8"?>
@@ -179,7 +225,7 @@
           <a:lstStyle/>
           <a:p>
             <a:r>
-              <a:rPr lang="en-US" smtClean="0"/>
+              <a:rPr lang="en-US"/>
               <a:t>Click to edit Master title style</a:t>
             </a:r>
             <a:endParaRPr lang="en-GB"/>
@@ -298,7 +344,7 @@
           </a:lstStyle>
           <a:p>
             <a:r>
-              <a:rPr lang="en-US" smtClean="0"/>
+              <a:rPr lang="en-US"/>
               <a:t>Click to edit Master subtitle style</a:t>
             </a:r>
             <a:endParaRPr lang="en-GB"/>
@@ -322,7 +368,7 @@
           <a:p>
             <a:fld id="{E6744CE3-0875-4B69-89C0-6F72D8139561}" type="datetimeFigureOut">
               <a:rPr lang="en-GB" smtClean="0"/>
-              <a:t>26/05/17</a:t>
+              <a:t>04/03/2026</a:t>
             </a:fld>
             <a:endParaRPr lang="en-GB"/>
           </a:p>
@@ -416,7 +462,7 @@
           <a:lstStyle/>
           <a:p>
             <a:r>
-              <a:rPr lang="en-US" smtClean="0"/>
+              <a:rPr lang="en-US"/>
               <a:t>Click to edit Master title style</a:t>
             </a:r>
             <a:endParaRPr lang="en-GB"/>
@@ -440,35 +486,35 @@
           <a:p>
             <a:pPr lvl="0"/>
             <a:r>
-              <a:rPr lang="en-US" smtClean="0"/>
+              <a:rPr lang="en-US"/>
               <a:t>Click to edit Master text styles</a:t>
             </a:r>
           </a:p>
           <a:p>
             <a:pPr lvl="1"/>
             <a:r>
-              <a:rPr lang="en-US" smtClean="0"/>
+              <a:rPr lang="en-US"/>
               <a:t>Second level</a:t>
             </a:r>
           </a:p>
           <a:p>
             <a:pPr lvl="2"/>
             <a:r>
-              <a:rPr lang="en-US" smtClean="0"/>
+              <a:rPr lang="en-US"/>
               <a:t>Third level</a:t>
             </a:r>
           </a:p>
           <a:p>
             <a:pPr lvl="3"/>
             <a:r>
-              <a:rPr lang="en-US" smtClean="0"/>
+              <a:rPr lang="en-US"/>
               <a:t>Fourth level</a:t>
             </a:r>
           </a:p>
           <a:p>
             <a:pPr lvl="4"/>
             <a:r>
-              <a:rPr lang="en-US" smtClean="0"/>
+              <a:rPr lang="en-US"/>
               <a:t>Fifth level</a:t>
             </a:r>
             <a:endParaRPr lang="en-GB"/>
@@ -492,7 +538,7 @@
           <a:p>
             <a:fld id="{E6744CE3-0875-4B69-89C0-6F72D8139561}" type="datetimeFigureOut">
               <a:rPr lang="en-GB" smtClean="0"/>
-              <a:t>26/05/17</a:t>
+              <a:t>04/03/2026</a:t>
             </a:fld>
             <a:endParaRPr lang="en-GB"/>
           </a:p>
@@ -595,7 +641,7 @@
           </a:lstStyle>
           <a:p>
             <a:r>
-              <a:rPr lang="en-US" smtClean="0"/>
+              <a:rPr lang="en-US"/>
               <a:t>Click to edit Master title style</a:t>
             </a:r>
             <a:endParaRPr lang="en-GB"/>
@@ -715,7 +761,7 @@
           <a:p>
             <a:pPr lvl="0"/>
             <a:r>
-              <a:rPr lang="en-US" smtClean="0"/>
+              <a:rPr lang="en-US"/>
               <a:t>Click to edit Master text styles</a:t>
             </a:r>
           </a:p>
@@ -738,7 +784,7 @@
           <a:p>
             <a:fld id="{E6744CE3-0875-4B69-89C0-6F72D8139561}" type="datetimeFigureOut">
               <a:rPr lang="en-GB" smtClean="0"/>
-              <a:t>26/05/17</a:t>
+              <a:t>04/03/2026</a:t>
             </a:fld>
             <a:endParaRPr lang="en-GB"/>
           </a:p>
@@ -832,7 +878,7 @@
           <a:lstStyle/>
           <a:p>
             <a:r>
-              <a:rPr lang="en-US" smtClean="0"/>
+              <a:rPr lang="en-US"/>
               <a:t>Click to edit Master title style</a:t>
             </a:r>
             <a:endParaRPr lang="en-GB"/>
@@ -889,35 +935,35 @@
           <a:p>
             <a:pPr lvl="0"/>
             <a:r>
-              <a:rPr lang="en-US" smtClean="0"/>
+              <a:rPr lang="en-US"/>
               <a:t>Click to edit Master text styles</a:t>
             </a:r>
           </a:p>
           <a:p>
             <a:pPr lvl="1"/>
             <a:r>
-              <a:rPr lang="en-US" smtClean="0"/>
+              <a:rPr lang="en-US"/>
               <a:t>Second level</a:t>
             </a:r>
           </a:p>
           <a:p>
             <a:pPr lvl="2"/>
             <a:r>
-              <a:rPr lang="en-US" smtClean="0"/>
+              <a:rPr lang="en-US"/>
               <a:t>Third level</a:t>
             </a:r>
           </a:p>
           <a:p>
             <a:pPr lvl="3"/>
             <a:r>
-              <a:rPr lang="en-US" smtClean="0"/>
+              <a:rPr lang="en-US"/>
               <a:t>Fourth level</a:t>
             </a:r>
           </a:p>
           <a:p>
             <a:pPr lvl="4"/>
             <a:r>
-              <a:rPr lang="en-US" smtClean="0"/>
+              <a:rPr lang="en-US"/>
               <a:t>Fifth level</a:t>
             </a:r>
             <a:endParaRPr lang="en-GB"/>
@@ -974,35 +1020,35 @@
           <a:p>
             <a:pPr lvl="0"/>
             <a:r>
-              <a:rPr lang="en-US" smtClean="0"/>
+              <a:rPr lang="en-US"/>
               <a:t>Click to edit Master text styles</a:t>
             </a:r>
           </a:p>
           <a:p>
             <a:pPr lvl="1"/>
             <a:r>
-              <a:rPr lang="en-US" smtClean="0"/>
+              <a:rPr lang="en-US"/>
               <a:t>Second level</a:t>
             </a:r>
           </a:p>
           <a:p>
             <a:pPr lvl="2"/>
             <a:r>
-              <a:rPr lang="en-US" smtClean="0"/>
+              <a:rPr lang="en-US"/>
               <a:t>Third level</a:t>
             </a:r>
           </a:p>
           <a:p>
             <a:pPr lvl="3"/>
             <a:r>
-              <a:rPr lang="en-US" smtClean="0"/>
+              <a:rPr lang="en-US"/>
               <a:t>Fourth level</a:t>
             </a:r>
           </a:p>
           <a:p>
             <a:pPr lvl="4"/>
             <a:r>
-              <a:rPr lang="en-US" smtClean="0"/>
+              <a:rPr lang="en-US"/>
               <a:t>Fifth level</a:t>
             </a:r>
             <a:endParaRPr lang="en-GB"/>
@@ -1026,7 +1072,7 @@
           <a:p>
             <a:fld id="{E6744CE3-0875-4B69-89C0-6F72D8139561}" type="datetimeFigureOut">
               <a:rPr lang="en-GB" smtClean="0"/>
-              <a:t>26/05/17</a:t>
+              <a:t>04/03/2026</a:t>
             </a:fld>
             <a:endParaRPr lang="en-GB"/>
           </a:p>
@@ -1124,7 +1170,7 @@
           </a:lstStyle>
           <a:p>
             <a:r>
-              <a:rPr lang="en-US" smtClean="0"/>
+              <a:rPr lang="en-US"/>
               <a:t>Click to edit Master title style</a:t>
             </a:r>
             <a:endParaRPr lang="en-GB"/>
@@ -1190,7 +1236,7 @@
           <a:p>
             <a:pPr lvl="0"/>
             <a:r>
-              <a:rPr lang="en-US" smtClean="0"/>
+              <a:rPr lang="en-US"/>
               <a:t>Click to edit Master text styles</a:t>
             </a:r>
           </a:p>
@@ -1246,35 +1292,35 @@
           <a:p>
             <a:pPr lvl="0"/>
             <a:r>
-              <a:rPr lang="en-US" smtClean="0"/>
+              <a:rPr lang="en-US"/>
               <a:t>Click to edit Master text styles</a:t>
             </a:r>
           </a:p>
           <a:p>
             <a:pPr lvl="1"/>
             <a:r>
-              <a:rPr lang="en-US" smtClean="0"/>
+              <a:rPr lang="en-US"/>
               <a:t>Second level</a:t>
             </a:r>
           </a:p>
           <a:p>
             <a:pPr lvl="2"/>
             <a:r>
-              <a:rPr lang="en-US" smtClean="0"/>
+              <a:rPr lang="en-US"/>
               <a:t>Third level</a:t>
             </a:r>
           </a:p>
           <a:p>
             <a:pPr lvl="3"/>
             <a:r>
-              <a:rPr lang="en-US" smtClean="0"/>
+              <a:rPr lang="en-US"/>
               <a:t>Fourth level</a:t>
             </a:r>
           </a:p>
           <a:p>
             <a:pPr lvl="4"/>
             <a:r>
-              <a:rPr lang="en-US" smtClean="0"/>
+              <a:rPr lang="en-US"/>
               <a:t>Fifth level</a:t>
             </a:r>
             <a:endParaRPr lang="en-GB"/>
@@ -1340,7 +1386,7 @@
           <a:p>
             <a:pPr lvl="0"/>
             <a:r>
-              <a:rPr lang="en-US" smtClean="0"/>
+              <a:rPr lang="en-US"/>
               <a:t>Click to edit Master text styles</a:t>
             </a:r>
           </a:p>
@@ -1396,35 +1442,35 @@
           <a:p>
             <a:pPr lvl="0"/>
             <a:r>
-              <a:rPr lang="en-US" smtClean="0"/>
+              <a:rPr lang="en-US"/>
               <a:t>Click to edit Master text styles</a:t>
             </a:r>
           </a:p>
           <a:p>
             <a:pPr lvl="1"/>
             <a:r>
-              <a:rPr lang="en-US" smtClean="0"/>
+              <a:rPr lang="en-US"/>
               <a:t>Second level</a:t>
             </a:r>
           </a:p>
           <a:p>
             <a:pPr lvl="2"/>
             <a:r>
-              <a:rPr lang="en-US" smtClean="0"/>
+              <a:rPr lang="en-US"/>
               <a:t>Third level</a:t>
             </a:r>
           </a:p>
           <a:p>
             <a:pPr lvl="3"/>
             <a:r>
-              <a:rPr lang="en-US" smtClean="0"/>
+              <a:rPr lang="en-US"/>
               <a:t>Fourth level</a:t>
             </a:r>
           </a:p>
           <a:p>
             <a:pPr lvl="4"/>
             <a:r>
-              <a:rPr lang="en-US" smtClean="0"/>
+              <a:rPr lang="en-US"/>
               <a:t>Fifth level</a:t>
             </a:r>
             <a:endParaRPr lang="en-GB"/>
@@ -1448,7 +1494,7 @@
           <a:p>
             <a:fld id="{E6744CE3-0875-4B69-89C0-6F72D8139561}" type="datetimeFigureOut">
               <a:rPr lang="en-GB" smtClean="0"/>
-              <a:t>26/05/17</a:t>
+              <a:t>04/03/2026</a:t>
             </a:fld>
             <a:endParaRPr lang="en-GB"/>
           </a:p>
@@ -1542,7 +1588,7 @@
           <a:lstStyle/>
           <a:p>
             <a:r>
-              <a:rPr lang="en-US" smtClean="0"/>
+              <a:rPr lang="en-US"/>
               <a:t>Click to edit Master title style</a:t>
             </a:r>
             <a:endParaRPr lang="en-GB"/>
@@ -1566,7 +1612,7 @@
           <a:p>
             <a:fld id="{E6744CE3-0875-4B69-89C0-6F72D8139561}" type="datetimeFigureOut">
               <a:rPr lang="en-GB" smtClean="0"/>
-              <a:t>26/05/17</a:t>
+              <a:t>04/03/2026</a:t>
             </a:fld>
             <a:endParaRPr lang="en-GB"/>
           </a:p>
@@ -1661,7 +1707,7 @@
           <a:p>
             <a:fld id="{E6744CE3-0875-4B69-89C0-6F72D8139561}" type="datetimeFigureOut">
               <a:rPr lang="en-GB" smtClean="0"/>
-              <a:t>26/05/17</a:t>
+              <a:t>04/03/2026</a:t>
             </a:fld>
             <a:endParaRPr lang="en-GB"/>
           </a:p>
@@ -1770,7 +1816,7 @@
           <a:lstStyle/>
           <a:p>
             <a:r>
-              <a:rPr lang="en-US" smtClean="0"/>
+              <a:rPr lang="en-US"/>
               <a:t>Click to edit Master title style</a:t>
             </a:r>
             <a:endParaRPr lang="en-GB"/>
@@ -1804,35 +1850,35 @@
           <a:p>
             <a:pPr lvl="0"/>
             <a:r>
-              <a:rPr lang="en-US" smtClean="0"/>
+              <a:rPr lang="en-US"/>
               <a:t>Click to edit Master text styles</a:t>
             </a:r>
           </a:p>
           <a:p>
             <a:pPr lvl="1"/>
             <a:r>
-              <a:rPr lang="en-US" smtClean="0"/>
+              <a:rPr lang="en-US"/>
               <a:t>Second level</a:t>
             </a:r>
           </a:p>
           <a:p>
             <a:pPr lvl="2"/>
             <a:r>
-              <a:rPr lang="en-US" smtClean="0"/>
+              <a:rPr lang="en-US"/>
               <a:t>Third level</a:t>
             </a:r>
           </a:p>
           <a:p>
             <a:pPr lvl="3"/>
             <a:r>
-              <a:rPr lang="en-US" smtClean="0"/>
+              <a:rPr lang="en-US"/>
               <a:t>Fourth level</a:t>
             </a:r>
           </a:p>
           <a:p>
             <a:pPr lvl="4"/>
             <a:r>
-              <a:rPr lang="en-US" smtClean="0"/>
+              <a:rPr lang="en-US"/>
               <a:t>Fifth level</a:t>
             </a:r>
             <a:endParaRPr lang="en-GB"/>
@@ -1874,7 +1920,7 @@
           <a:p>
             <a:fld id="{E6744CE3-0875-4B69-89C0-6F72D8139561}" type="datetimeFigureOut">
               <a:rPr lang="en-GB" smtClean="0"/>
-              <a:t>26/05/17</a:t>
+              <a:t>04/03/2026</a:t>
             </a:fld>
             <a:endParaRPr lang="en-GB"/>
           </a:p>
@@ -2266,7 +2312,6 @@
           <a:lstStyle/>
           <a:p>
             <a:r>
-              <a:rPr/>
               <a:t>Hist Num Stores</a:t>
             </a:r>
           </a:p>
@@ -2274,7 +2319,7 @@
       </p:sp>
       <p:pic>
         <p:nvPicPr>
-          <p:cNvPr id="3" name="Content Placeholder 2" descr=""/>
+          <p:cNvPr id="3" name="Content Placeholder 2"/>
           <p:cNvPicPr>
             <a:picLocks noGrp="1"/>
           </p:cNvPicPr>
@@ -2344,7 +2389,6 @@
           <a:lstStyle/>
           <a:p>
             <a:r>
-              <a:rPr/>
               <a:t>Demeaned Scatter Footfall Vs Nob</a:t>
             </a:r>
           </a:p>
@@ -2352,7 +2396,7 @@
       </p:sp>
       <p:pic>
         <p:nvPicPr>
-          <p:cNvPr id="3" name="Content Placeholder 2" descr=""/>
+          <p:cNvPr id="3" name="Content Placeholder 2"/>
           <p:cNvPicPr>
             <a:picLocks noGrp="1"/>
           </p:cNvPicPr>
@@ -2422,7 +2466,6 @@
           <a:lstStyle/>
           <a:p>
             <a:r>
-              <a:rPr/>
               <a:t>Nob Vs Footfall Store Panels</a:t>
             </a:r>
           </a:p>
@@ -2430,7 +2473,7 @@
       </p:sp>
       <p:pic>
         <p:nvPicPr>
-          <p:cNvPr id="3" name="Content Placeholder 2" descr=""/>
+          <p:cNvPr id="3" name="Content Placeholder 2"/>
           <p:cNvPicPr>
             <a:picLocks noGrp="1"/>
           </p:cNvPicPr>
@@ -2500,7 +2543,6 @@
           <a:lstStyle/>
           <a:p>
             <a:r>
-              <a:rPr/>
               <a:t>State Mall Metrics Table</a:t>
             </a:r>
           </a:p>
@@ -2508,7 +2550,7 @@
       </p:sp>
       <p:pic>
         <p:nvPicPr>
-          <p:cNvPr id="3" name="Content Placeholder 2" descr=""/>
+          <p:cNvPr id="3" name="Content Placeholder 2"/>
           <p:cNvPicPr>
             <a:picLocks noGrp="1"/>
           </p:cNvPicPr>
@@ -2578,7 +2620,6 @@
           <a:lstStyle/>
           <a:p>
             <a:r>
-              <a:rPr/>
               <a:t>City Mall Metrics Table</a:t>
             </a:r>
           </a:p>
@@ -2586,7 +2627,7 @@
       </p:sp>
       <p:pic>
         <p:nvPicPr>
-          <p:cNvPr id="3" name="Content Placeholder 2" descr=""/>
+          <p:cNvPr id="3" name="Content Placeholder 2"/>
           <p:cNvPicPr>
             <a:picLocks noGrp="1"/>
           </p:cNvPicPr>
@@ -2656,7 +2697,6 @@
           <a:lstStyle/>
           <a:p>
             <a:r>
-              <a:rPr/>
               <a:t>Store Type Distribution</a:t>
             </a:r>
           </a:p>
@@ -2664,7 +2704,7 @@
       </p:sp>
       <p:pic>
         <p:nvPicPr>
-          <p:cNvPr id="3" name="Content Placeholder 2" descr=""/>
+          <p:cNvPr id="3" name="Content Placeholder 2"/>
           <p:cNvPicPr>
             <a:picLocks noGrp="1"/>
           </p:cNvPicPr>
@@ -2734,7 +2774,6 @@
           <a:lstStyle/>
           <a:p>
             <a:r>
-              <a:rPr/>
               <a:t>Store Classification Distribution</a:t>
             </a:r>
           </a:p>
@@ -2742,7 +2781,7 @@
       </p:sp>
       <p:pic>
         <p:nvPicPr>
-          <p:cNvPr id="3" name="Content Placeholder 2" descr=""/>
+          <p:cNvPr id="3" name="Content Placeholder 2"/>
           <p:cNvPicPr>
             <a:picLocks noGrp="1"/>
           </p:cNvPicPr>
@@ -2812,7 +2851,6 @@
           <a:lstStyle/>
           <a:p>
             <a:r>
-              <a:rPr/>
               <a:t>Area By Store Classification Boxplot</a:t>
             </a:r>
           </a:p>
@@ -2820,7 +2858,7 @@
       </p:sp>
       <p:pic>
         <p:nvPicPr>
-          <p:cNvPr id="3" name="Content Placeholder 2" descr=""/>
+          <p:cNvPr id="3" name="Content Placeholder 2"/>
           <p:cNvPicPr>
             <a:picLocks noGrp="1"/>
           </p:cNvPicPr>
@@ -2890,7 +2928,6 @@
           <a:lstStyle/>
           <a:p>
             <a:r>
-              <a:rPr/>
               <a:t>Carpet Area Vs Avg Footfall</a:t>
             </a:r>
           </a:p>
@@ -2898,7 +2935,7 @@
       </p:sp>
       <p:pic>
         <p:nvPicPr>
-          <p:cNvPr id="3" name="Content Placeholder 2" descr=""/>
+          <p:cNvPr id="3" name="Content Placeholder 2"/>
           <p:cNvPicPr>
             <a:picLocks noGrp="1"/>
           </p:cNvPicPr>
@@ -2968,7 +3005,6 @@
           <a:lstStyle/>
           <a:p>
             <a:r>
-              <a:rPr/>
               <a:t>Carpet Area Vs Avg Nob</a:t>
             </a:r>
           </a:p>
@@ -2976,7 +3012,7 @@
       </p:sp>
       <p:pic>
         <p:nvPicPr>
-          <p:cNvPr id="3" name="Content Placeholder 2" descr=""/>
+          <p:cNvPr id="3" name="Content Placeholder 2"/>
           <p:cNvPicPr>
             <a:picLocks noGrp="1"/>
           </p:cNvPicPr>
@@ -3046,7 +3082,6 @@
           <a:lstStyle/>
           <a:p>
             <a:r>
-              <a:rPr/>
               <a:t>Wave Vs Demeaned Footfall</a:t>
             </a:r>
           </a:p>
@@ -3054,7 +3089,7 @@
       </p:sp>
       <p:pic>
         <p:nvPicPr>
-          <p:cNvPr id="3" name="Content Placeholder 2" descr=""/>
+          <p:cNvPr id="3" name="Content Placeholder 2"/>
           <p:cNvPicPr>
             <a:picLocks noGrp="1"/>
           </p:cNvPicPr>
@@ -3124,7 +3159,6 @@
           <a:lstStyle/>
           <a:p>
             <a:r>
-              <a:rPr/>
               <a:t>City Summary Metrics</a:t>
             </a:r>
           </a:p>
@@ -3132,7 +3166,7 @@
       </p:sp>
       <p:pic>
         <p:nvPicPr>
-          <p:cNvPr id="3" name="Content Placeholder 2" descr=""/>
+          <p:cNvPr id="3" name="Content Placeholder 2"/>
           <p:cNvPicPr>
             <a:picLocks noGrp="1"/>
           </p:cNvPicPr>
@@ -3202,7 +3236,6 @@
           <a:lstStyle/>
           <a:p>
             <a:r>
-              <a:rPr/>
               <a:t>Wave Vs Demeaned Nob</a:t>
             </a:r>
           </a:p>
@@ -3210,7 +3243,7 @@
       </p:sp>
       <p:pic>
         <p:nvPicPr>
-          <p:cNvPr id="3" name="Content Placeholder 2" descr=""/>
+          <p:cNvPr id="3" name="Content Placeholder 2"/>
           <p:cNvPicPr>
             <a:picLocks noGrp="1"/>
           </p:cNvPicPr>
@@ -3280,7 +3313,6 @@
           <a:lstStyle/>
           <a:p>
             <a:r>
-              <a:rPr/>
               <a:t>Wave Vs Demeaned Footfall Points</a:t>
             </a:r>
           </a:p>
@@ -3288,7 +3320,7 @@
       </p:sp>
       <p:pic>
         <p:nvPicPr>
-          <p:cNvPr id="3" name="Content Placeholder 2" descr=""/>
+          <p:cNvPr id="3" name="Content Placeholder 2"/>
           <p:cNvPicPr>
             <a:picLocks noGrp="1"/>
           </p:cNvPicPr>
@@ -3358,7 +3390,6 @@
           <a:lstStyle/>
           <a:p>
             <a:r>
-              <a:rPr/>
               <a:t>Wave Vs Demeaned Nob Points</a:t>
             </a:r>
           </a:p>
@@ -3366,7 +3397,7 @@
       </p:sp>
       <p:pic>
         <p:nvPicPr>
-          <p:cNvPr id="3" name="Content Placeholder 2" descr=""/>
+          <p:cNvPr id="3" name="Content Placeholder 2"/>
           <p:cNvPicPr>
             <a:picLocks noGrp="1"/>
           </p:cNvPicPr>
@@ -3436,7 +3467,6 @@
           <a:lstStyle/>
           <a:p>
             <a:r>
-              <a:rPr/>
               <a:t>Col Summary</a:t>
             </a:r>
           </a:p>
@@ -3444,7 +3474,7 @@
       </p:sp>
       <p:pic>
         <p:nvPicPr>
-          <p:cNvPr id="3" name="Content Placeholder 2" descr=""/>
+          <p:cNvPr id="3" name="Content Placeholder 2"/>
           <p:cNvPicPr>
             <a:picLocks noGrp="1"/>
           </p:cNvPicPr>
@@ -3514,7 +3544,6 @@
           <a:lstStyle/>
           <a:p>
             <a:r>
-              <a:rPr/>
               <a:t>Product Option Descriptives 2025</a:t>
             </a:r>
           </a:p>
@@ -3522,7 +3551,7 @@
       </p:sp>
       <p:pic>
         <p:nvPicPr>
-          <p:cNvPr id="3" name="Content Placeholder 2" descr=""/>
+          <p:cNvPr id="3" name="Content Placeholder 2"/>
           <p:cNvPicPr>
             <a:picLocks noGrp="1"/>
           </p:cNvPicPr>
@@ -3592,7 +3621,6 @@
           <a:lstStyle/>
           <a:p>
             <a:r>
-              <a:rPr/>
               <a:t>Top5 Products Option Count</a:t>
             </a:r>
           </a:p>
@@ -3600,7 +3628,7 @@
       </p:sp>
       <p:pic>
         <p:nvPicPr>
-          <p:cNvPr id="3" name="Content Placeholder 2" descr=""/>
+          <p:cNvPr id="3" name="Content Placeholder 2"/>
           <p:cNvPicPr>
             <a:picLocks noGrp="1"/>
           </p:cNvPicPr>
@@ -3670,7 +3698,6 @@
           <a:lstStyle/>
           <a:p>
             <a:r>
-              <a:rPr/>
               <a:t>Brand Nsv Summary</a:t>
             </a:r>
           </a:p>
@@ -3678,7 +3705,7 @@
       </p:sp>
       <p:pic>
         <p:nvPicPr>
-          <p:cNvPr id="3" name="Content Placeholder 2" descr=""/>
+          <p:cNvPr id="3" name="Content Placeholder 2"/>
           <p:cNvPicPr>
             <a:picLocks noGrp="1"/>
           </p:cNvPicPr>
@@ -3748,7 +3775,6 @@
           <a:lstStyle/>
           <a:p>
             <a:r>
-              <a:rPr/>
               <a:t>Brand Qty Summary</a:t>
             </a:r>
           </a:p>
@@ -3756,7 +3782,7 @@
       </p:sp>
       <p:pic>
         <p:nvPicPr>
-          <p:cNvPr id="3" name="Content Placeholder 2" descr=""/>
+          <p:cNvPr id="3" name="Content Placeholder 2"/>
           <p:cNvPicPr>
             <a:picLocks noGrp="1"/>
           </p:cNvPicPr>
@@ -3826,7 +3852,6 @@
           <a:lstStyle/>
           <a:p>
             <a:r>
-              <a:rPr/>
               <a:t>Type Vs Sales Summary</a:t>
             </a:r>
           </a:p>
@@ -3834,7 +3859,7 @@
       </p:sp>
       <p:pic>
         <p:nvPicPr>
-          <p:cNvPr id="3" name="Content Placeholder 2" descr=""/>
+          <p:cNvPr id="3" name="Content Placeholder 2"/>
           <p:cNvPicPr>
             <a:picLocks noGrp="1"/>
           </p:cNvPicPr>
@@ -3904,7 +3929,6 @@
           <a:lstStyle/>
           <a:p>
             <a:r>
-              <a:rPr/>
               <a:t>Fashion Pyramid Vs Sales Summary</a:t>
             </a:r>
           </a:p>
@@ -3912,7 +3936,7 @@
       </p:sp>
       <p:pic>
         <p:nvPicPr>
-          <p:cNvPr id="3" name="Content Placeholder 2" descr=""/>
+          <p:cNvPr id="3" name="Content Placeholder 2"/>
           <p:cNvPicPr>
             <a:picLocks noGrp="1"/>
           </p:cNvPicPr>
@@ -3982,7 +4006,6 @@
           <a:lstStyle/>
           <a:p>
             <a:r>
-              <a:rPr/>
               <a:t>Hist Stores Per State</a:t>
             </a:r>
           </a:p>
@@ -3990,7 +4013,7 @@
       </p:sp>
       <p:pic>
         <p:nvPicPr>
-          <p:cNvPr id="3" name="Content Placeholder 2" descr=""/>
+          <p:cNvPr id="3" name="Content Placeholder 2"/>
           <p:cNvPicPr>
             <a:picLocks noGrp="1"/>
           </p:cNvPicPr>
@@ -4060,7 +4083,6 @@
           <a:lstStyle/>
           <a:p>
             <a:r>
-              <a:rPr/>
               <a:t>Ag Description Summary</a:t>
             </a:r>
           </a:p>
@@ -4068,7 +4090,7 @@
       </p:sp>
       <p:pic>
         <p:nvPicPr>
-          <p:cNvPr id="3" name="Content Placeholder 2" descr=""/>
+          <p:cNvPr id="3" name="Content Placeholder 2"/>
           <p:cNvPicPr>
             <a:picLocks noGrp="1"/>
           </p:cNvPicPr>
@@ -4138,7 +4160,6 @@
           <a:lstStyle/>
           <a:p>
             <a:r>
-              <a:rPr/>
               <a:t>Newsimplifiedproduct Nsv Descriptives</a:t>
             </a:r>
           </a:p>
@@ -4146,7 +4167,7 @@
       </p:sp>
       <p:pic>
         <p:nvPicPr>
-          <p:cNvPr id="3" name="Content Placeholder 2" descr=""/>
+          <p:cNvPr id="3" name="Content Placeholder 2"/>
           <p:cNvPicPr>
             <a:picLocks noGrp="1"/>
           </p:cNvPicPr>
@@ -4216,7 +4237,6 @@
           <a:lstStyle/>
           <a:p>
             <a:r>
-              <a:rPr/>
               <a:t>Newsimplifiedproduct Qty Descriptives</a:t>
             </a:r>
           </a:p>
@@ -4224,7 +4244,7 @@
       </p:sp>
       <p:pic>
         <p:nvPicPr>
-          <p:cNvPr id="3" name="Content Placeholder 2" descr=""/>
+          <p:cNvPr id="3" name="Content Placeholder 2"/>
           <p:cNvPicPr>
             <a:picLocks noGrp="1"/>
           </p:cNvPicPr>
@@ -4249,6 +4269,89 @@
         </p:spPr>
       </p:pic>
     </p:spTree>
+  </p:cSld>
+  <p:clrMapOvr>
+    <a:masterClrMapping/>
+  </p:clrMapOvr>
+</p:sld>
+</file>
+
+<file path=ppt/slides/slide33.xml><?xml version="1.0" encoding="utf-8"?>
+<p:sld xmlns:a="http://schemas.openxmlformats.org/drawingml/2006/main" xmlns:r="http://schemas.openxmlformats.org/officeDocument/2006/relationships" xmlns:p="http://schemas.openxmlformats.org/presentationml/2006/main">
+  <p:cSld>
+    <p:spTree>
+      <p:nvGrpSpPr>
+        <p:cNvPr id="1" name=""/>
+        <p:cNvGrpSpPr/>
+        <p:nvPr/>
+      </p:nvGrpSpPr>
+      <p:grpSpPr>
+        <a:xfrm>
+          <a:off x="0" y="0"/>
+          <a:ext cx="0" cy="0"/>
+          <a:chOff x="0" y="0"/>
+          <a:chExt cx="0" cy="0"/>
+        </a:xfrm>
+      </p:grpSpPr>
+      <p:sp>
+        <p:nvSpPr>
+          <p:cNvPr id="2" name="Title 1">
+            <a:extLst>
+              <a:ext uri="{FF2B5EF4-FFF2-40B4-BE49-F238E27FC236}">
+                <a16:creationId xmlns:a16="http://schemas.microsoft.com/office/drawing/2014/main" id="{6B9C9EBF-4F03-7DA7-E505-32DE54D0DBBA}"/>
+              </a:ext>
+            </a:extLst>
+          </p:cNvPr>
+          <p:cNvSpPr>
+            <a:spLocks noGrp="1"/>
+          </p:cNvSpPr>
+          <p:nvPr>
+            <p:ph type="title"/>
+          </p:nvPr>
+        </p:nvSpPr>
+        <p:spPr/>
+        <p:txBody>
+          <a:bodyPr/>
+          <a:lstStyle/>
+          <a:p>
+            <a:r>
+              <a:rPr lang="en-SG"/>
+              <a:t>Test</a:t>
+            </a:r>
+          </a:p>
+        </p:txBody>
+      </p:sp>
+      <p:sp>
+        <p:nvSpPr>
+          <p:cNvPr id="3" name="Content Placeholder 2">
+            <a:extLst>
+              <a:ext uri="{FF2B5EF4-FFF2-40B4-BE49-F238E27FC236}">
+                <a16:creationId xmlns:a16="http://schemas.microsoft.com/office/drawing/2014/main" id="{54780A54-B4DC-DDF4-6045-ABC994E917B7}"/>
+              </a:ext>
+            </a:extLst>
+          </p:cNvPr>
+          <p:cNvSpPr>
+            <a:spLocks noGrp="1"/>
+          </p:cNvSpPr>
+          <p:nvPr>
+            <p:ph idx="1"/>
+          </p:nvPr>
+        </p:nvSpPr>
+        <p:spPr/>
+        <p:txBody>
+          <a:bodyPr/>
+          <a:lstStyle/>
+          <a:p>
+            <a:endParaRPr lang="en-SG"/>
+          </a:p>
+        </p:txBody>
+      </p:sp>
+    </p:spTree>
+    <p:extLst>
+      <p:ext uri="{BB962C8B-B14F-4D97-AF65-F5344CB8AC3E}">
+        <p14:creationId xmlns:p14="http://schemas.microsoft.com/office/powerpoint/2010/main" val="1463186371"/>
+      </p:ext>
+    </p:extLst>
   </p:cSld>
   <p:clrMapOvr>
     <a:masterClrMapping/>
@@ -4294,7 +4397,6 @@
           <a:lstStyle/>
           <a:p>
             <a:r>
-              <a:rPr/>
               <a:t>State Summary Metrics</a:t>
             </a:r>
           </a:p>
@@ -4302,7 +4404,7 @@
       </p:sp>
       <p:pic>
         <p:nvPicPr>
-          <p:cNvPr id="3" name="Content Placeholder 2" descr=""/>
+          <p:cNvPr id="3" name="Content Placeholder 2"/>
           <p:cNvPicPr>
             <a:picLocks noGrp="1"/>
           </p:cNvPicPr>
@@ -4372,7 +4474,6 @@
           <a:lstStyle/>
           <a:p>
             <a:r>
-              <a:rPr/>
               <a:t>Type Summary Table</a:t>
             </a:r>
           </a:p>
@@ -4380,7 +4481,7 @@
       </p:sp>
       <p:pic>
         <p:nvPicPr>
-          <p:cNvPr id="3" name="Content Placeholder 2" descr=""/>
+          <p:cNvPr id="3" name="Content Placeholder 2"/>
           <p:cNvPicPr>
             <a:picLocks noGrp="1"/>
           </p:cNvPicPr>
@@ -4450,7 +4551,6 @@
           <a:lstStyle/>
           <a:p>
             <a:r>
-              <a:rPr/>
               <a:t>Classification Summary Table</a:t>
             </a:r>
           </a:p>
@@ -4458,7 +4558,7 @@
       </p:sp>
       <p:pic>
         <p:nvPicPr>
-          <p:cNvPr id="3" name="Content Placeholder 2" descr=""/>
+          <p:cNvPr id="3" name="Content Placeholder 2"/>
           <p:cNvPicPr>
             <a:picLocks noGrp="1"/>
           </p:cNvPicPr>
@@ -4528,7 +4628,6 @@
           <a:lstStyle/>
           <a:p>
             <a:r>
-              <a:rPr/>
               <a:t>Classification Vs Area Table</a:t>
             </a:r>
           </a:p>
@@ -4536,7 +4635,7 @@
       </p:sp>
       <p:pic>
         <p:nvPicPr>
-          <p:cNvPr id="3" name="Content Placeholder 2" descr=""/>
+          <p:cNvPr id="3" name="Content Placeholder 2"/>
           <p:cNvPicPr>
             <a:picLocks noGrp="1"/>
           </p:cNvPicPr>
@@ -4606,7 +4705,6 @@
           <a:lstStyle/>
           <a:p>
             <a:r>
-              <a:rPr/>
               <a:t>Overall Metrics Table</a:t>
             </a:r>
           </a:p>
@@ -4614,7 +4712,7 @@
       </p:sp>
       <p:pic>
         <p:nvPicPr>
-          <p:cNvPr id="3" name="Content Placeholder 2" descr=""/>
+          <p:cNvPr id="3" name="Content Placeholder 2"/>
           <p:cNvPicPr>
             <a:picLocks noGrp="1"/>
           </p:cNvPicPr>
@@ -4684,7 +4782,6 @@
           <a:lstStyle/>
           <a:p>
             <a:r>
-              <a:rPr/>
               <a:t>Scatter Nob Vs Footfall</a:t>
             </a:r>
           </a:p>
@@ -4692,7 +4789,7 @@
       </p:sp>
       <p:pic>
         <p:nvPicPr>
-          <p:cNvPr id="3" name="Content Placeholder 2" descr=""/>
+          <p:cNvPr id="3" name="Content Placeholder 2"/>
           <p:cNvPicPr>
             <a:picLocks noGrp="1"/>
           </p:cNvPicPr>

</xml_diff>